<commit_message>
Use the shared "Class question" phrasing in the Session 4 deck notes
Co-Authored-By: Claude Fable 5.1 <noreply@anthropic.com>
</commit_message>
<xml_diff>
--- a/presentations/m5-session-4-sub-agents-teams-and-the-discipline.pptx
+++ b/presentations/m5-session-4-sub-agents-teams-and-the-discipline.pptx
@@ -523,7 +523,7 @@
           <a:lstStyle/>
           <a:p>
             <a:r>
-              <a:t>Last session we built one harness and measured it. Today the question is what happens when one agent is not enough: the context fills up, the task has independent parts, or a specialist is needed. We cover the shapes - sub-agents, teams, handoffs - the failure modes, and then step back to what the discipline demands. Part 2 is notebook 04 and lab 4. Ask the class: when you split a job between people, what usually goes wrong first?</a:t>
+              <a:t>Last session we built one harness and measured it. Today the question is what happens when one agent is not enough: the context fills up, the task has independent parts, or a specialist is needed. We cover the shapes - sub-agents, teams, handoffs - the failure modes, and then step back to what the discipline demands. Part 2 is notebook 04 and lab 4. Class question: when you split a job between people, what usually goes wrong first?</a:t>
             </a:r>
           </a:p>
         </p:txBody>
@@ -593,7 +593,7 @@
           <a:lstStyle/>
           <a:p>
             <a:r>
-              <a:t>Left column is the course in six lines; right column is the gap. Read them as pairs: instruction files exist but are not enforced; security rules exist but 4.4% have a control; permission prompts exist but 93% are waved through; and 60% of harnesses could not tell you whether their last change helped. The eleven-harness study found the same thing from the code side: the loops are hand-rolled and the retrieval is deterministic - engineering, not magic. Ask the class: which of the six did your notebook 03 harness already have?</a:t>
+              <a:t>Left column is the course in six lines; right column is the gap. Read them as pairs: instruction files exist but are not enforced; security rules exist but 4.4% have a control; permission prompts exist but 93% are waved through; and 60% of harnesses could not tell you whether their last change helped. The eleven-harness study found the same thing from the code side: the loops are hand-rolled and the retrieval is deterministic - engineering, not magic. Class question: which of the six did your notebook 03 harness already have?</a:t>
             </a:r>
           </a:p>
         </p:txBody>
@@ -663,7 +663,7 @@
           <a:lstStyle/>
           <a:p>
             <a:r>
-              <a:t>Read it twice. It is the most reassuring sentence in the module: the systems students read about - Claude Code, Codex CLI, Gemini CLI, Aider, OpenHands and the rest - are loops, tool registries and file search, written by hand. The harness package in this course is the same species, smaller. Ask the class: after four sessions, which line of the harness package would you now want to read in one of those eleven?</a:t>
+              <a:t>Read it twice. It is the most reassuring sentence in the module: the systems students read about - Claude Code, Codex CLI, Gemini CLI, Aider, OpenHands and the rest - are loops, tool registries and file search, written by hand. The harness package in this course is the same species, smaller. Class question: after four sessions, which line of the harness package would you now want to read in one of those eleven?</a:t>
             </a:r>
           </a:p>
         </p:txBody>
@@ -733,7 +733,7 @@
           <a:lstStyle/>
           <a:p>
             <a:r>
-              <a:t>Four signposts, all dated, none speculative. Repositories are being rewritten for agent readers; skills let one folder work across forty platforms; twenty-one thousand harness repos in one year says everyone is building the same car; and the discipline now has a name and a first anatomy paper. The closing line of the module: models are bought, harnesses are built. Ask the class: which of the eight pieces do you think will be standardized next, after tools (MCP) and skills?</a:t>
+              <a:t>Four signposts, all dated, none speculative. Repositories are being rewritten for agent readers; skills let one folder work across forty platforms; twenty-one thousand harness repos in one year says everyone is building the same car; and the discipline now has a name and a first anatomy paper. The closing line of the module: models are bought, harnesses are built. Class question: which of the eight pieces do you think will be standardized next, after tools (MCP) and skills?</a:t>
             </a:r>
           </a:p>
         </p:txBody>
@@ -803,7 +803,7 @@
           <a:lstStyle/>
           <a:p>
             <a:r>
-              <a:t>Open notebook 04. Everything runs on real Claude models: claude-opus-5 leads and synthesizes, claude-sonnet-5 does the reading, and the agents read files of this repository, so every answer can be checked by opening the file. The key sits in the git-ignored .env at the repository root and only load_client() reads it. The numbers on the next slides are from the run recorded on 30 September 2026, which cost 0.4413 USD for the whole notebook; a live run will differ in wording, in the route the model takes and in cents. Ask the class: which of the three shapes do you expect to cost the most tokens, and why?</a:t>
+              <a:t>Open notebook 04. Everything runs on real Claude models: claude-opus-5 leads and synthesizes, claude-sonnet-5 does the reading, and the agents read files of this repository, so every answer can be checked by opening the file. The key sits in the git-ignored .env at the repository root and only load_client() reads it. The numbers on the next slides are from the run recorded on 30 September 2026, which cost 0.4413 USD for the whole notebook; a live run will differ in wording, in the route the model takes and in cents. Class question: which of the three shapes do you expect to cost the most tokens, and why?</a:t>
             </a:r>
           </a:p>
         </p:txBody>
@@ -873,7 +873,7 @@
           <a:lstStyle/>
           <a:p>
             <a:r>
-              <a:t>The chart has two kinds of bar on purpose. The navy bars are context sizes - what one agent was carrying at the end, counted by the API on the exact messages. The sky bar is the sum of the three workers' final contexts, which never touched the lead's window. Say the honest part out loud: on this three-part question the solo agent on opus-5 was not polluted. It read exactly the three files it needed, answered all three parts, and cost less and finished in a third of the time because it made no detours. The lesson is 'scale effort to the query': the sub-agent design earns its cost when the question has ten facts or the files are ten times longer, because then the solo context keeps growing and you cannot tell which fact it dropped without a grader. Ask the class: how would you change the question so that the solo agent does drop a part?</a:t>
+              <a:t>The chart has two kinds of bar on purpose. The navy bars are context sizes - what one agent was carrying at the end, counted by the API on the exact messages. The sky bar is the sum of the three workers' final contexts, which never touched the lead's window. Say the honest part out loud: on this three-part question the solo agent on opus-5 was not polluted. It read exactly the three files it needed, answered all three parts, and cost less and finished in a third of the time because it made no detours. The lesson is 'scale effort to the query': the sub-agent design earns its cost when the question has ten facts or the files are ten times longer, because then the solo context keeps growing and you cannot tell which fact it dropped without a grader. Class question: how would you change the question so that the solo agent does drop a part?</a:t>
             </a:r>
           </a:p>
         </p:txBody>
@@ -943,7 +943,7 @@
           <a:lstStyle/>
           <a:p>
             <a:r>
-              <a:t>Walk the board top to bottom: the three teammates claimed one task each at the start, and whoever finished first took the next open task, so each ended with two. The right panel is the only thing the team buys: the clock. The six worker runs happen either way, so the tokens and the cost are the same; parallel work moved 19.9 seconds of work into 7.5. The four-teammate exercise makes the point twice: with six tasks and four hands you still need two rounds, so nothing is saved and the cost is unchanged. Ask the class: what breaks first if two teammates claim the same task at the same time, and which line of TaskBoard prevents it?</a:t>
+              <a:t>Walk the board top to bottom: the three teammates claimed one task each at the start, and whoever finished first took the next open task, so each ended with two. The right panel is the only thing the team buys: the clock. The six worker runs happen either way, so the tokens and the cost are the same; parallel work moved 19.9 seconds of work into 7.5. The four-teammate exercise makes the point twice: with six tasks and four hands you still need two rounds, so nothing is saved and the cost is unchanged. Class question: what breaks first if two teammates claim the same task at the same time, and which line of TaskBoard prevents it?</a:t>
             </a:r>
           </a:p>
         </p:txBody>
@@ -1013,7 +1013,7 @@
           <a:lstStyle/>
           <a:p>
             <a:r>
-              <a:t>The handoff is the simplest of the three shapes and the easiest to overuse. The calculator specialist gets the entire research conversation and one new instruction; it needs only the two numbers, but pays for the README the worker read, its tool calls and its answer - 7,017 tokens on the first call and again on the second. That is why the survey found chains of more than four handoffs almost always fail: the history grows and the intent blurs. Ask the class: when is inheriting the full history actually necessary, and what would a summary lose in that case?</a:t>
+              <a:t>The handoff is the simplest of the three shapes and the easiest to overuse. The calculator specialist gets the entire research conversation and one new instruction; it needs only the two numbers, but pays for the README the worker read, its tool calls and its answer - 7,017 tokens on the first call and again on the second. That is why the survey found chains of more than four handoffs almost always fail: the history grows and the intent blurs. Class question: when is inheriting the full history actually necessary, and what would a summary lose in that case?</a:t>
             </a:r>
           </a:p>
         </p:txBody>
@@ -1083,7 +1083,7 @@
           <a:lstStyle/>
           <a:p>
             <a:r>
-              <a:t>This is Session 3's stop conditions made visible on a real model. Nothing is staged: the task is simply open-ended, and a worker will list folders and read files for as long as it is allowed. Each call re-sends the previous tool results, so the bars grow, slowly while it lists and then in a jump when it asks for fourteen files at once. The dashed line is the budget; the hatched bar is the call the harness measured with count_tokens and never sent. The text box is the other seatbelt, max_turns=4, which stopped a second run after four calls. Neither produced a summary; together they cost about seven cents. A trace is how you notice a runaway before the invoice does. Ask the class: what would a smarter guard look at, so it could stop this task after the second call instead of the fifth?</a:t>
+              <a:t>This is Session 3's stop conditions made visible on a real model. Nothing is staged: the task is simply open-ended, and a worker will list folders and read files for as long as it is allowed. Each call re-sends the previous tool results, so the bars grow, slowly while it lists and then in a jump when it asks for fourteen files at once. The dashed line is the budget; the hatched bar is the call the harness measured with count_tokens and never sent. The text box is the other seatbelt, max_turns=4, which stopped a second run after four calls. Neither produced a summary; together they cost about seven cents. A trace is how you notice a runaway before the invoice does. Class question: what would a smarter guard look at, so it could stop this task after the second call instead of the fifth?</a:t>
             </a:r>
           </a:p>
         </p:txBody>
@@ -1153,7 +1153,7 @@
           <a:lstStyle/>
           <a:p>
             <a:r>
-              <a:t>Read the table with the 'answered' column in hand. The team answered six questions, the others the same three-part question, so the number to compare is the cost per answered question - and in this run it was roughly flat everywhere, between 1.2 and 1.5 cents, because every answer needs its own listing, reading and writing. The team cost 1.8 times the solo agent for twice the questions. The one outlier is the handoff: five cents for a single answer, because the specialist carried the whole research conversation on both of its calls. What multiplies is the number of contexts doing the reading, plus the coordination on top, and coordination on the strong model is the expensive part. Anthropic's research system paid fifteen times the tokens for its 90.2 percent gain: a good trade for a hard question, a terrible one for a lookup. Ask the class: which row would you delete from your own design first, and what eval would you run before adding it back?</a:t>
+              <a:t>Read the table with the 'answered' column in hand. The team answered six questions, the others the same three-part question, so the number to compare is the cost per answered question - and in this run it was roughly flat everywhere, between 1.2 and 1.5 cents, because every answer needs its own listing, reading and writing. The team cost 1.8 times the solo agent for twice the questions. The one outlier is the handoff: five cents for a single answer, because the specialist carried the whole research conversation on both of its calls. What multiplies is the number of contexts doing the reading, plus the coordination on top, and coordination on the strong model is the expensive part. Anthropic's research system paid fifteen times the tokens for its 90.2 percent gain: a good trade for a hard question, a terrible one for a lookup. Class question: which row would you delete from your own design first, and what eval would you run before adding it back?</a:t>
             </a:r>
           </a:p>
         </p:txBody>
@@ -1223,7 +1223,7 @@
           <a:lstStyle/>
           <a:p>
             <a:r>
-              <a:t>Left is the whole subagent: YAML front matter and a system prompt. Map the fields to the notebook - name is Agent(name=...), description is the delegate tool's docstring written for a machine, tools is the allow-list, model is WORKER_MODEL, maxTurns is max_turns. Right is the PostToolUse log after the first observed run: seven tool calls happened inside the subagent, including a 2,583-character file read, and the main agent received a single 3,284-character result. That is section 1 of the notebook in eight log lines. The trap question is the second lesson: the subagent answered correctly that the repository does not contain a dean, but it searched only the lab folder, because --add-dir allows a read and does not tell the model where to look - teach the orchestrator how to delegate. Ask the class: which front matter field would you change so that the fact-checker subagent can never be given write tools by mistake?</a:t>
+              <a:t>Left is the whole subagent: YAML front matter and a system prompt. Map the fields to the notebook - name is Agent(name=...), description is the delegate tool's docstring written for a machine, tools is the allow-list, model is WORKER_MODEL, maxTurns is max_turns. Right is the PostToolUse log after the first observed run: seven tool calls happened inside the subagent, including a 2,583-character file read, and the main agent received a single 3,284-character result. That is section 1 of the notebook in eight log lines. The trap question is the second lesson: the subagent answered correctly that the repository does not contain a dean, but it searched only the lab folder, because --add-dir allows a read and does not tell the model where to look - teach the orchestrator how to delegate. Class question: which front matter field would you change so that the fact-checker subagent can never be given write tools by mistake?</a:t>
             </a:r>
           </a:p>
         </p:txBody>
@@ -1293,7 +1293,7 @@
           <a:lstStyle/>
           <a:p>
             <a:r>
-              <a:t>Part 1 moves from one agent to many: why to isolate context, the three shapes, the failure modes, and then the discipline itself. Ask the class: what is the most agents you have seen cooperate on one task, and did it help?</a:t>
+              <a:t>Part 1 moves from one agent to many: why to isolate context, the three shapes, the failure modes, and then the discipline itself. Class question: what is the most agents you have seen cooperate on one task, and did it help?</a:t>
             </a:r>
           </a:p>
         </p:txBody>
@@ -1363,7 +1363,7 @@
           <a:lstStyle/>
           <a:p>
             <a:r>
-              <a:t>Two layers, two observed runs. Asked outright to cat the key file, the model refused by itself and no tool ran - the instruction file worked, and the lab says why that is not enough: a differently worded request, a long session or a compaction can make a sentence go missing. Asked for something that sounds harmless - does the file exist and how big is it - the model tried, and the hook stopped the call before it ran; the model read the reason and adapted instead of retrying, which is notebook 03's is_error tool result as a product. Notice the log has no line for the blocked call: the brakes and the dashboard are different instruments. On the right, the modes are the permission argument with more shapes, dontAsk is what you use when nobody is there to answer, and agent teams are one environment variable away - interactive only, so the recorded runs could not form one. Ask the class: which of these four controls would you add to your notebook 03 harness first, and why that one?</a:t>
+              <a:t>Two layers, two observed runs. Asked outright to cat the key file, the model refused by itself and no tool ran - the instruction file worked, and the lab says why that is not enough: a differently worded request, a long session or a compaction can make a sentence go missing. Asked for something that sounds harmless - does the file exist and how big is it - the model tried, and the hook stopped the call before it ran; the model read the reason and adapted instead of retrying, which is notebook 03's is_error tool result as a product. Notice the log has no line for the blocked call: the brakes and the dashboard are different instruments. On the right, the modes are the permission argument with more shapes, dontAsk is what you use when nobody is there to answer, and agent teams are one environment variable away - interactive only, so the recorded runs could not form one. Class question: which of these four controls would you add to your notebook 03 harness first, and why that one?</a:t>
             </a:r>
           </a:p>
         </p:txBody>
@@ -1433,7 +1433,7 @@
           <a:lstStyle/>
           <a:p>
             <a:r>
-              <a:t>Close the loop with Session 1's anatomy slide: the same eight pieces, now with the notebook or lab where each one was built on real components - the Anthropic SDK, the harness package, Claude Code and GitHub Actions. Students have run every one of them. The point of the middle column is that the car metaphor was never decoration - each piece answers one question a driver would ask. Ask the class: which piece would you replace first if this harness went to production, and with what?</a:t>
+              <a:t>Close the loop with Session 1's anatomy slide: the same eight pieces, now with the notebook or lab where each one was built on real components - the Anthropic SDK, the harness package, Claude Code and GitHub Actions. Students have run every one of them. The point of the middle column is that the car metaphor was never decoration - each piece answers one question a driver would ask. Class question: which piece would you replace first if this harness went to production, and with what?</a:t>
             </a:r>
           </a:p>
         </p:txBody>
@@ -1503,7 +1503,7 @@
           <a:lstStyle/>
           <a:p>
             <a:r>
-              <a:t>End on capability, not theory. Every line is something they ran this module, on real models and real tools, with the bill printed after every experiment. The last line is the invitation: the parts they built by hand exist as product features, and now they can read those features for what they are. Ask the class: what is the first agent you would build with this, and which of the eight pieces would you spend most of your time on?</a:t>
+              <a:t>End on capability, not theory. Every line is something they ran this module, on real models and real tools, with the bill printed after every experiment. The last line is the invitation: the parts they built by hand exist as product features, and now they can read those features for what they are. Class question: what is the first agent you would build with this, and which of the eight pieces would you spend most of your time on?</a:t>
             </a:r>
           </a:p>
         </p:txBody>
@@ -1573,7 +1573,7 @@
           <a:lstStyle/>
           <a:p>
             <a:r>
-              <a:t>Start from the problem, not the pattern: in Session 2 the context window was a budget, and compaction was the emergency brake. Sub-agents are the structural fix - the expensive exploration happens in a window you throw away, and only a short summary comes back. Point at the arrow widths: gray brief out, blue summary back, nothing else crosses. Ask the class: what would you lose if the sub-agent returned its whole transcript instead of a summary?</a:t>
+              <a:t>Start from the problem, not the pattern: in Session 2 the context window was a budget, and compaction was the emergency brake. Sub-agents are the structural fix - the expensive exploration happens in a window you throw away, and only a short summary comes back. Point at the arrow widths: gray brief out, blue summary back, nothing else crosses. Class question: what would you lose if the sub-agent returned its whole transcript instead of a summary?</a:t>
             </a:r>
           </a:p>
         </p:txBody>
@@ -1643,7 +1643,7 @@
           <a:lstStyle/>
           <a:p>
             <a:r>
-              <a:t>The number that made multi-agent systems respectable: a lead Opus with parallel Sonnet sub-agents beat a lone Opus by 90.2% on breadth-first research questions. Then say the second half of the label louder than the first: fifteen times the tokens of a normal chat. The gain came from parallel exploration across separate context windows - exactly the isolation from the previous slide. Ask the class: which kinds of task would NOT benefit from splitting - and why?</a:t>
+              <a:t>The number that made multi-agent systems respectable: a lead Opus with parallel Sonnet sub-agents beat a lone Opus by 90.2% on breadth-first research questions. Then say the second half of the label louder than the first: fifteen times the tokens of a normal chat. The gain came from parallel exploration across separate context windows - exactly the isolation from the previous slide. Class question: which kinds of task would NOT benefit from splitting - and why?</a:t>
             </a:r>
           </a:p>
         </p:txBody>
@@ -1713,7 +1713,7 @@
           <a:lstStyle/>
           <a:p>
             <a:r>
-              <a:t>Two columns, two owners. The left is prompt work for the lead: it must brief its workers like a good manager - objective, format, tools, boundaries - and decide how much effort a question deserves. The right is harness work: parallelism, memory, a citation pass, evals. Notice that the fix for wandering sub-agents was not a smarter model; it was a better brief. Ask the class: write a one-line brief for a sub-agent that should find when function calling shipped - what would you include?</a:t>
+              <a:t>Two columns, two owners. The left is prompt work for the lead: it must brief its workers like a good manager - objective, format, tools, boundaries - and decide how much effort a question deserves. The right is harness work: parallelism, memory, a citation pass, evals. Notice that the fix for wandering sub-agents was not a smarter model; it was a better brief. Class question: write a one-line brief for a sub-agent that should find when function calling shipped - what would you include?</a:t>
             </a:r>
           </a:p>
         </p:txBody>
@@ -1783,7 +1783,7 @@
           <a:lstStyle/>
           <a:p>
             <a:r>
-              <a:t>Same three pictures every time you design a multi-agent system. Hierarchy: one lead, workers that report up and never talk sideways - simple and predictable. Flat team: a shared task list, teammates that claim work and message each other, a lead that assigns and synthesizes - more parallel, harder to reason about. Handoff: the conversation itself moves to a specialist and the first agent steps back. In plain words: a convoy, a crew with one job board, a change of drivers. Ask the class: which shape is a hospital triage desk?</a:t>
+              <a:t>Same three pictures every time you design a multi-agent system. Hierarchy: one lead, workers that report up and never talk sideways - simple and predictable. Flat team: a shared task list, teammates that claim work and message each other, a lead that assigns and synthesizes - more parallel, harder to reason about. Handoff: the conversation itself moves to a specialist and the first agent steps back. In plain words: a convoy, a crew with one job board, a change of drivers. Class question: which shape is a hospital triage desk?</a:t>
             </a:r>
           </a:p>
         </p:txBody>
@@ -1853,7 +1853,7 @@
           <a:lstStyle/>
           <a:p>
             <a:r>
-              <a:t>Use the table as a decision aid, row by row. The communication row is the one students miss: sub-agents cannot talk to each other by design, which is a feature - no cross-contamination - until two of them need the same fact. Teams fix that with a board and a mailbox at the price of coordination. Handoffs are different in kind: nothing is summarized, the receiver gets everything. Ask the class: you have 40 independent documents to summarize - which column, and what is the risk?</a:t>
+              <a:t>Use the table as a decision aid, row by row. The communication row is the one students miss: sub-agents cannot talk to each other by design, which is a feature - no cross-contamination - until two of them need the same fact. Teams fix that with a board and a mailbox at the price of coordination. Handoffs are different in kind: nothing is summarized, the receiver gets everything. Class question: you have 40 independent documents to summarize - which column, and what is the risk?</a:t>
             </a:r>
           </a:p>
         </p:txBody>
@@ -1923,7 +1923,7 @@
           <a:lstStyle/>
           <a:p>
             <a:r>
-              <a:t>This is Session 3's workflow-versus-agent choice, one level up. On the left, orchestration is a Python function: the plan is a list, the loop is a for-loop, the merge is a call. On the right, orchestration is a tool the lead may call, and the structure lives in the model's head. Notebook 04 runs both on the same three-part question; the totals came out close (0.0415 against 0.0444 USD) because the reading is the same and only the coordination differs: two cheap planner and synthesizer calls against two calls on the expensive lead model. Ask the class: which side would you pick for a nightly report that must look the same every day?</a:t>
+              <a:t>This is Session 3's workflow-versus-agent choice, one level up. On the left, orchestration is a Python function: the plan is a list, the loop is a for-loop, the merge is a call. On the right, orchestration is a tool the lead may call, and the structure lives in the model's head. Notebook 04 runs both on the same three-part question; the totals came out close (0.0415 against 0.0444 USD) because the reading is the same and only the coordination differs: two cheap planner and synthesizer calls against two calls on the expensive lead model. Class question: which side would you pick for a nightly report that must look the same every day?</a:t>
             </a:r>
           </a:p>
         </p:txBody>
@@ -1993,7 +1993,7 @@
           <a:lstStyle/>
           <a:p>
             <a:r>
-              <a:t>Every row is a real incident type; the last one is the notebook's own exercise - a before_tool hook that denies a third delegation. In the recorded run the hook never had to fire: told about the cap in its system prompt, the lead planned two workers, one of them covering two files, and answered all three parts for slightly less than the uncapped lead. The two survey findings deserve emphasis: chains of more than four handoffs almost always failed - each handoff loses intent - and adding a reviewer agent made things worse by eight points, probably because the reviewer second-guessed correct answers. The lesson is not 'never add agents'; it is 'never add an agent without an eval that shows it helped'. Ask the class: which of these six would a trace catch first?</a:t>
+              <a:t>Every row is a real incident type; the last one is the notebook's own exercise - a before_tool hook that denies a third delegation. In the recorded run the hook never had to fire: told about the cap in its system prompt, the lead planned two workers, one of them covering two files, and answered all three parts for slightly less than the uncapped lead. The two survey findings deserve emphasis: chains of more than four handoffs almost always failed - each handoff loses intent - and adding a reviewer agent made things worse by eight points, probably because the reviewer second-guessed correct answers. The lesson is not 'never add agents'; it is 'never add an agent without an eval that shows it helped'. Class question: which of these six would a trace catch first?</a:t>
             </a:r>
           </a:p>
         </p:txBody>

</xml_diff>

<commit_message>
Refresh the Session 4 deck from the re-executed notebook 04
Every Part 2 figure and the two Part 1 slides that quote the run now
come from the 2 October run on the final package: lead 1,938 versus
solo 3,962 context tokens with both answering all three parts,
orchestrator 0.0311 versus lead 0.0519 USD, the team clearing six tasks
in 9.5 s against 28.3 s summed, 6,965 inherited tokens on the handoff,
the max_turns and budget stops (five model calls, next call measured at
16,136 tokens), and the cost table. Lab slides unchanged. 22 slides.

Co-Authored-By: Claude Fable 5.1 <noreply@anthropic.com>
</commit_message>
<xml_diff>
--- a/presentations/m5-session-4-sub-agents-teams-and-the-discipline.pptx
+++ b/presentations/m5-session-4-sub-agents-teams-and-the-discipline.pptx
@@ -803,7 +803,7 @@
           <a:lstStyle/>
           <a:p>
             <a:r>
-              <a:t>Open notebook 04. Everything runs on real Claude models: claude-opus-5 leads and synthesizes, claude-sonnet-5 does the reading, and the agents read files of this repository, so every answer can be checked by opening the file. The key sits in the git-ignored .env at the repository root and only load_client() reads it. The numbers on the next slides are from the run recorded on 30 September 2026, which cost 0.4413 USD for the whole notebook; a live run will differ in wording, in the route the model takes and in cents. Class question: which of the three shapes do you expect to cost the most tokens, and why?</a:t>
+              <a:t>Open notebook 04. Everything runs on real Claude models: claude-opus-5 leads and synthesizes, claude-sonnet-5 does the reading, and the agents read files of this repository, so every answer can be checked by opening the file. The key sits in the git-ignored .env at the repository root and only load_client() reads it. The numbers on the next slides are from the run recorded on 2 October 2026, which cost 0.4313 USD for the whole notebook; a live run will differ in wording, in the route the model takes and in cents. Class question: which of the three shapes do you expect to cost the most tokens, and why?</a:t>
             </a:r>
           </a:p>
         </p:txBody>
@@ -873,7 +873,7 @@
           <a:lstStyle/>
           <a:p>
             <a:r>
-              <a:t>The chart has two kinds of bar on purpose. The navy bars are context sizes - what one agent was carrying at the end, counted by the API on the exact messages. The sky bar is the sum of the three workers' final contexts, which never touched the lead's window. Say the honest part out loud: on this three-part question the solo agent on opus-5 was not polluted. It read exactly the three files it needed, answered all three parts, and cost less and finished in a third of the time because it made no detours. The lesson is 'scale effort to the query': the sub-agent design earns its cost when the question has ten facts or the files are ten times longer, because then the solo context keeps growing and you cannot tell which fact it dropped without a grader. Class question: how would you change the question so that the solo agent does drop a part?</a:t>
+              <a:t>The chart has two kinds of bar on purpose. The navy bars are context sizes - what one agent was carrying at the end, counted by the API on the exact messages. The sky bar is the sum of the three workers' final contexts, which never touched the lead's window. Say the honest part out loud: on this three-part question the solo agent on opus-5 was not polluted. It read exactly the three files it needed, answered all three parts, and cost less and finished in a fraction of the time (7.4 against 34.1 seconds) because it made no detours. The lesson is 'scale effort to the query': the sub-agent design earns its cost when the question has ten facts or the files are ten times longer, because then the solo context keeps growing and you cannot tell which fact it dropped without a grader. Class question: how would you change the question so that the solo agent does drop a part?</a:t>
             </a:r>
           </a:p>
         </p:txBody>
@@ -943,7 +943,7 @@
           <a:lstStyle/>
           <a:p>
             <a:r>
-              <a:t>Walk the board top to bottom: the three teammates claimed one task each at the start, and whoever finished first took the next open task, so each ended with two. The right panel is the only thing the team buys: the clock. The six worker runs happen either way, so the tokens and the cost are the same; parallel work moved 19.9 seconds of work into 7.5. The four-teammate exercise makes the point twice: with six tasks and four hands you still need two rounds, so nothing is saved and the cost is unchanged. Class question: what breaks first if two teammates claim the same task at the same time, and which line of TaskBoard prevents it?</a:t>
+              <a:t>Walk the board top to bottom: the three teammates claimed one task each at the start, and whoever finished first took the next open task, so each ended with two. The right panel is the only thing the team buys: the clock. The six worker runs happen either way, so the tokens and the cost are the same; parallel work moved 28.3 seconds of work into 9.5. The four-teammate exercise makes the point twice: with six tasks and four hands you still need two rounds, so there is little to save - that run was slower, 13.1 seconds, at the same cost. Class question: what breaks first if two teammates claim the same task at the same time, and which line of TaskBoard prevents it?</a:t>
             </a:r>
           </a:p>
         </p:txBody>
@@ -1013,7 +1013,7 @@
           <a:lstStyle/>
           <a:p>
             <a:r>
-              <a:t>The handoff is the simplest of the three shapes and the easiest to overuse. The calculator specialist gets the entire research conversation and one new instruction; it needs only the two numbers, but pays for the README the worker read, its tool calls and its answer - 7,017 tokens on the first call and again on the second. That is why the survey found chains of more than four handoffs almost always fail: the history grows and the intent blurs. Class question: when is inheriting the full history actually necessary, and what would a summary lose in that case?</a:t>
+              <a:t>The handoff is the simplest of the three shapes and the easiest to overuse. The calculator specialist gets the entire research conversation and one new instruction; it needs only the two numbers, but pays for the README the worker read, its tool calls and its answer - 6,965 tokens on the first call and again on the second. That is why the survey found chains of more than four handoffs almost always fail: the history grows and the intent blurs. Class question: when is inheriting the full history actually necessary, and what would a summary lose in that case?</a:t>
             </a:r>
           </a:p>
         </p:txBody>
@@ -1083,7 +1083,7 @@
           <a:lstStyle/>
           <a:p>
             <a:r>
-              <a:t>This is Session 3's stop conditions made visible on a real model. Nothing is staged: the task is simply open-ended, and a worker will list folders and read files for as long as it is allowed. Each call re-sends the previous tool results, so the bars grow, slowly while it lists and then in a jump when it asks for fourteen files at once. The dashed line is the budget; the hatched bar is the call the harness measured with count_tokens and never sent. The text box is the other seatbelt, max_turns=4, which stopped a second run after four calls. Neither produced a summary; together they cost about seven cents. A trace is how you notice a runaway before the invoice does. Class question: what would a smarter guard look at, so it could stop this task after the second call instead of the fifth?</a:t>
+              <a:t>This is Session 3's stop conditions made visible on a real model. Nothing is staged: the task is simply open-ended, and a worker will list folders and read files for as long as it is allowed. Each call re-sends the previous tool results, so the bars grow, slowly while it lists and then in a jump when it asks for ten files at once. The dashed line is the budget; the hatched bar is the call the harness measured with count_tokens and never sent. The text box is the other seatbelt, max_turns=4, which stopped a second run after four calls. Neither produced a summary; together they cost under seven cents. A trace is how you notice a runaway before the invoice does. Class question: what would a smarter guard look at, so it could stop this task after the second call instead of the fifth?</a:t>
             </a:r>
           </a:p>
         </p:txBody>
@@ -1153,7 +1153,7 @@
           <a:lstStyle/>
           <a:p>
             <a:r>
-              <a:t>Read the table with the 'answered' column in hand. The team answered six questions, the others the same three-part question, so the number to compare is the cost per answered question - and in this run it was roughly flat everywhere, between 1.2 and 1.5 cents, because every answer needs its own listing, reading and writing. The team cost 1.8 times the solo agent for twice the questions. The one outlier is the handoff: five cents for a single answer, because the specialist carried the whole research conversation on both of its calls. What multiplies is the number of contexts doing the reading, plus the coordination on top, and coordination on the strong model is the expensive part. Anthropic's research system paid fifteen times the tokens for its 90.2 percent gain: a good trade for a hard question, a terrible one for a lookup. Class question: which row would you delete from your own design first, and what eval would you run before adding it back?</a:t>
+              <a:t>Read the table with the 'answered' column in hand. The team answered six questions, the others the same three-part question, so the number to compare is the cost per answered question - and in this run it ran from 1.0 cent for the orchestrator to 1.7 for the lead, because every answer needs its own listing, reading and writing. The team cost 1.8 times the solo agent for twice the questions. The one outlier is the handoff: five cents for a single answer, because the specialist carried the whole research conversation on both of its calls. What multiplies is the number of contexts doing the reading, plus the coordination on top, and coordination on the strong model is the expensive part. Anthropic's research system paid fifteen times the tokens for its 90.2 percent gain: a good trade for a hard question, a terrible one for a lookup. Class question: which row would you delete from your own design first, and what eval would you run before adding it back?</a:t>
             </a:r>
           </a:p>
         </p:txBody>
@@ -1923,7 +1923,7 @@
           <a:lstStyle/>
           <a:p>
             <a:r>
-              <a:t>This is Session 3's workflow-versus-agent choice, one level up. On the left, orchestration is a Python function: the plan is a list, the loop is a for-loop, the merge is a call. On the right, orchestration is a tool the lead may call, and the structure lives in the model's head. Notebook 04 runs both on the same three-part question; the totals came out close (0.0415 against 0.0444 USD) because the reading is the same and only the coordination differs: two cheap planner and synthesizer calls against two calls on the expensive lead model. Class question: which side would you pick for a nightly report that must look the same every day?</a:t>
+              <a:t>This is Session 3's workflow-versus-agent choice, one level up. On the left, orchestration is a Python function: the plan is a list, the loop is a for-loop, the merge is a call. On the right, orchestration is a tool the lead may call, and the structure lives in the model's head. Notebook 04 runs both on the same three-part question; both split it into three sub-questions, and the orchestrator came out cheaper (0.0311 against 0.0519 USD) and faster (10.7 against 21.0 seconds): its two coordination calls cost 0.0104 USD on the worker model where the lead's two calls on claude-opus-5 cost 0.0278, and its workers ran in a thread pool while the lead's delegations ran one after another. Class question: which side would you pick for a nightly report that must look the same every day?</a:t>
             </a:r>
           </a:p>
         </p:txBody>
@@ -1993,7 +1993,7 @@
           <a:lstStyle/>
           <a:p>
             <a:r>
-              <a:t>Every row is a real incident type; the last one is the notebook's own exercise - a before_tool hook that denies a third delegation. In the recorded run the hook never had to fire: told about the cap in its system prompt, the lead planned two workers, one of them covering two files, and answered all three parts for slightly less than the uncapped lead. The two survey findings deserve emphasis: chains of more than four handoffs almost always failed - each handoff loses intent - and adding a reviewer agent made things worse by eight points, probably because the reviewer second-guessed correct answers. The lesson is not 'never add agents'; it is 'never add an agent without an eval that shows it helped'. Class question: which of these six would a trace catch first?</a:t>
+              <a:t>Every row is a real incident type; the last one is the notebook's own exercise - a before_tool hook that denies a third delegation. In the recorded run the hook never had to fire: told about the cap in its system prompt, the lead planned two workers, one of them covering two files, and answered all three parts for 0.0414 USD against 0.0519 for the uncapped lead. The two survey findings deserve emphasis: chains of more than four handoffs almost always failed - each handoff loses intent - and adding a reviewer agent made things worse by eight points, probably because the reviewer second-guessed correct answers. The lesson is not 'never add agents'; it is 'never add an agent without an eval that shows it helped'. Class question: which of these six would a trace catch first?</a:t>
             </a:r>
           </a:p>
         </p:txBody>
@@ -7277,7 +7277,7 @@
                 </a:solidFill>
                 <a:latin typeface="Arial"/>
               </a:rPr>
-              <a:t>Lead: 1,527 tokens of final context; solo agent: 3,985</a:t>
+              <a:t>Lead: 1,938 tokens of final context; solo agent: 3,962</a:t>
             </a:r>
           </a:p>
         </p:txBody>
@@ -7404,7 +7404,7 @@
                 </a:solidFill>
                 <a:latin typeface="Arial"/>
               </a:rPr>
-              <a:t>It made 3 delegate calls in one turn and 2 model calls; it holds three reports, not three files: 1,527 tokens</a:t>
+              <a:t>It made 3 delegate calls in one turn and 2 model calls; it holds three reports, not three files: 1,938 tokens</a:t>
             </a:r>
           </a:p>
           <a:p>
@@ -7424,7 +7424,7 @@
                 </a:solidFill>
                 <a:latin typeface="Arial"/>
               </a:rPr>
-              <a:t>The solo agent read the same three files itself: 3 model calls, 5 tool calls, 3,985 tokens, about 2.5x the lead</a:t>
+              <a:t>The solo agent read the same three files itself: 3 model calls, 5 tool calls, 3,962 tokens, about 2x the lead</a:t>
             </a:r>
           </a:p>
           <a:p>
@@ -7444,7 +7444,7 @@
                 </a:solidFill>
                 <a:latin typeface="Arial"/>
               </a:rPr>
-              <a:t>Plainly: the solo agent was not polluted here. It answered 3 of 3 parts, cheaper (0.0402 vs 0.0444 USD) and faster</a:t>
+              <a:t>Plainly: the solo agent was not polluted here. It answered 3 of 3 parts, cheaper (0.0397 vs 0.0519 USD) and faster</a:t>
             </a:r>
           </a:p>
           <a:p>
@@ -7528,7 +7528,7 @@
                 </a:solidFill>
                 <a:latin typeface="Arial"/>
               </a:rPr>
-              <a:t>Recorded run on claude-opus-5 (lead) and claude-sonnet-5 (workers), 30 Sep 2026; live runs vary. count_tokens on each agent's final message list (notebook 04, section 1).</a:t>
+              <a:t>Recorded run on claude-opus-5 (lead) and claude-sonnet-5 (workers), 2 Oct 2026; live runs vary. count_tokens on each agent's final message list (notebook 04, section 1).</a:t>
             </a:r>
           </a:p>
         </p:txBody>
@@ -7794,7 +7794,7 @@
                 </a:solidFill>
                 <a:latin typeface="Arial"/>
               </a:rPr>
-              <a:t>Three teammates cleared six tasks in 7.5 s, not 19.9 s</a:t>
+              <a:t>Three teammates cleared six tasks in 9.5 s, not 28.3 s</a:t>
             </a:r>
           </a:p>
         </p:txBody>
@@ -7941,7 +7941,7 @@
                 </a:solidFill>
                 <a:latin typeface="Arial"/>
               </a:rPr>
-              <a:t>17 model calls, 10 tool calls, 0.0706 USD including the team lead's briefing on opus-5; the six answers are gradable</a:t>
+              <a:t>17 model calls, 10 tool calls, 0.0722 USD including the team lead's briefing on opus-5; the six answers are gradable</a:t>
             </a:r>
           </a:p>
           <a:p>
@@ -7961,7 +7961,7 @@
                 </a:solidFill>
                 <a:latin typeface="Arial"/>
               </a:rPr>
-              <a:t>Exercise 2, four teammates: 7.9 s and 0.0715 USD - the same within noise, because six tasks still take two rounds</a:t>
+              <a:t>Exercise 2, four teammates: 13.1 s and 0.0707 USD - no faster and the same cost, because six tasks still take two rounds</a:t>
             </a:r>
           </a:p>
           <a:p>
@@ -8045,7 +8045,7 @@
                 </a:solidFill>
                 <a:latin typeface="Arial"/>
               </a:rPr>
-              <a:t>Recorded run on claude-opus-5 (lead) and claude-sonnet-5 (workers), 30 Sep 2026; live runs vary. TaskBoard, three threads, tasks from evals/cases.yaml (notebook 04, section 3).</a:t>
+              <a:t>Recorded run on claude-opus-5 (lead) and claude-sonnet-5 (workers), 2 Oct 2026; live runs vary. TaskBoard, three threads, tasks from evals/cases.yaml (notebook 04, section 3).</a:t>
             </a:r>
           </a:p>
         </p:txBody>
@@ -8311,7 +8311,7 @@
                 </a:solidFill>
                 <a:latin typeface="Arial"/>
               </a:rPr>
-              <a:t>A handoff carries everything: 7,017 inherited tokens</a:t>
+              <a:t>A handoff carries everything: 6,965 inherited tokens</a:t>
             </a:r>
           </a:p>
         </p:txBody>
@@ -8458,7 +8458,7 @@
                 </a:solidFill>
                 <a:latin typeface="Arial"/>
               </a:rPr>
-              <a:t>First model call: 7,539 input tokens; a fresh calculator on the same sum: 522. Inherited: 7,017</a:t>
+              <a:t>First model call: 7,487 input tokens; a fresh calculator on the same sum: 522. Inherited: 6,965</a:t>
             </a:r>
           </a:p>
           <a:p>
@@ -8478,7 +8478,7 @@
                 </a:solidFill>
                 <a:latin typeface="Arial"/>
               </a:rPr>
-              <a:t>0.0514 USD for one answer, 0.0029 fresh. Delegation asks for a report; a handoff hands over</a:t>
+              <a:t>0.0509 USD for one answer, 0.0029 fresh. Delegation asks for a report; a handoff hands over</a:t>
             </a:r>
           </a:p>
           <a:p>
@@ -8562,7 +8562,7 @@
                 </a:solidFill>
                 <a:latin typeface="Arial"/>
               </a:rPr>
-              <a:t>Recorded run on claude-opus-5 (lead) and claude-sonnet-5 (workers), 30 Sep 2026; live runs vary. Input tokens from the trace of the first model call (notebook 04, section 4).</a:t>
+              <a:t>Recorded run on claude-opus-5 (lead) and claude-sonnet-5 (workers), 2 Oct 2026; live runs vary. Input tokens from the trace of the first model call (notebook 04, section 4).</a:t>
             </a:r>
           </a:p>
         </p:txBody>
@@ -8955,7 +8955,7 @@
                 </a:solidFill>
                 <a:latin typeface="Arial"/>
               </a:rPr>
-              <a:t>Seatbelt 1, max_turns=4: stopped_because = 'max_turns' after 4 model calls and 23 tool calls, 0.0279 USD</a:t>
+              <a:t>Seatbelt 1, max_turns=4: stopped_because = 'max_turns' after 4 model calls and 21 tool calls, 0.0272 USD</a:t>
             </a:r>
           </a:p>
           <a:p>
@@ -8975,7 +8975,7 @@
                 </a:solidFill>
                 <a:latin typeface="Arial"/>
               </a:rPr>
-              <a:t>Seatbelt 2, max_input_tokens=12,000: the calls saw 738, 991, 2,197, 3,587 and 4,112 tokens as folders were listed</a:t>
+              <a:t>Seatbelt 2, max_input_tokens=12,000: the calls saw 765, 1,001, 2,180, 3,414 and 3,672 tokens as folders were listed</a:t>
             </a:r>
           </a:p>
           <a:p>
@@ -8995,7 +8995,7 @@
                 </a:solidFill>
                 <a:latin typeface="Arial"/>
               </a:rPr>
-              <a:t>Then the worker asked for a whole batch of files; count_tokens measured the next call at 17,810 and the loop refused to send it</a:t>
+              <a:t>Then the worker asked for a whole batch of files; count_tokens measured the next call at 16,136 and the loop refused to send it</a:t>
             </a:r>
           </a:p>
           <a:p>
@@ -9015,7 +9015,7 @@
                 </a:solidFill>
                 <a:latin typeface="Arial"/>
               </a:rPr>
-              <a:t>stopped_because = 'budget', 37 tool calls, 0.0450 USD, no summary. Both runs together: 0.0729 USD for nothing</a:t>
+              <a:t>stopped_because = 'budget' after 5 model calls and 31 tool calls, 0.0397 USD, no summary. Both runs: 0.0669 USD for nothing</a:t>
             </a:r>
           </a:p>
         </p:txBody>
@@ -9079,7 +9079,7 @@
                 </a:solidFill>
                 <a:latin typeface="Arial"/>
               </a:rPr>
-              <a:t>Recorded run on claude-opus-5 (lead) and claude-sonnet-5 (workers), 30 Sep 2026; live runs vary. Trace input tokens per call; call 6 is the count_tokens figure (nb 04, 5.1).</a:t>
+              <a:t>Recorded run on claude-opus-5 (lead) and claude-sonnet-5 (workers), 2 Oct 2026; live runs vary. Trace input tokens per call; call 6 is the count_tokens figure (nb 04, 5.1).</a:t>
             </a:r>
           </a:p>
         </p:txBody>
@@ -9780,7 +9780,7 @@
                           </a:solidFill>
                           <a:latin typeface="Arial"/>
                         </a:rPr>
-                        <a:t>10,081</a:t>
+                        <a:t>10,583</a:t>
                       </a:r>
                     </a:p>
                   </a:txBody>
@@ -9808,7 +9808,7 @@
                           </a:solidFill>
                           <a:latin typeface="Arial"/>
                         </a:rPr>
-                        <a:t>995</a:t>
+                        <a:t>1,406</a:t>
                       </a:r>
                     </a:p>
                   </a:txBody>
@@ -9836,7 +9836,7 @@
                           </a:solidFill>
                           <a:latin typeface="Arial"/>
                         </a:rPr>
-                        <a:t>0.0444</a:t>
+                        <a:t>0.0519</a:t>
                       </a:r>
                     </a:p>
                   </a:txBody>
@@ -9892,7 +9892,7 @@
                           </a:solidFill>
                           <a:latin typeface="Arial"/>
                         </a:rPr>
-                        <a:t>0.0148</a:t>
+                        <a:t>0.0173</a:t>
                       </a:r>
                     </a:p>
                   </a:txBody>
@@ -9920,7 +9920,7 @@
                           </a:solidFill>
                           <a:latin typeface="Arial"/>
                         </a:rPr>
-                        <a:t>1.1</a:t>
+                        <a:t>1.3</a:t>
                       </a:r>
                     </a:p>
                   </a:txBody>
@@ -10034,7 +10034,7 @@
                           </a:solidFill>
                           <a:latin typeface="Arial"/>
                         </a:rPr>
-                        <a:t>5,702</a:t>
+                        <a:t>5,713</a:t>
                       </a:r>
                     </a:p>
                   </a:txBody>
@@ -10062,7 +10062,7 @@
                           </a:solidFill>
                           <a:latin typeface="Arial"/>
                         </a:rPr>
-                        <a:t>469</a:t>
+                        <a:t>444</a:t>
                       </a:r>
                     </a:p>
                   </a:txBody>
@@ -10090,7 +10090,7 @@
                           </a:solidFill>
                           <a:latin typeface="Arial"/>
                         </a:rPr>
-                        <a:t>0.0402</a:t>
+                        <a:t>0.0397</a:t>
                       </a:r>
                     </a:p>
                   </a:txBody>
@@ -10146,7 +10146,7 @@
                           </a:solidFill>
                           <a:latin typeface="Arial"/>
                         </a:rPr>
-                        <a:t>0.0134</a:t>
+                        <a:t>0.0132</a:t>
                       </a:r>
                     </a:p>
                   </a:txBody>
@@ -10232,7 +10232,7 @@
                           </a:solidFill>
                           <a:latin typeface="Arial"/>
                         </a:rPr>
-                        <a:t>12</a:t>
+                        <a:t>9</a:t>
                       </a:r>
                     </a:p>
                   </a:txBody>
@@ -10260,7 +10260,7 @@
                           </a:solidFill>
                           <a:latin typeface="Arial"/>
                         </a:rPr>
-                        <a:t>6</a:t>
+                        <a:t>4</a:t>
                       </a:r>
                     </a:p>
                   </a:txBody>
@@ -10288,7 +10288,7 @@
                           </a:solidFill>
                           <a:latin typeface="Arial"/>
                         </a:rPr>
-                        <a:t>12,519</a:t>
+                        <a:t>9,008</a:t>
                       </a:r>
                     </a:p>
                   </a:txBody>
@@ -10316,7 +10316,7 @@
                           </a:solidFill>
                           <a:latin typeface="Arial"/>
                         </a:rPr>
-                        <a:t>1,074</a:t>
+                        <a:t>825</a:t>
                       </a:r>
                     </a:p>
                   </a:txBody>
@@ -10344,7 +10344,7 @@
                           </a:solidFill>
                           <a:latin typeface="Arial"/>
                         </a:rPr>
-                        <a:t>0.0415</a:t>
+                        <a:t>0.0311</a:t>
                       </a:r>
                     </a:p>
                   </a:txBody>
@@ -10400,7 +10400,7 @@
                           </a:solidFill>
                           <a:latin typeface="Arial"/>
                         </a:rPr>
-                        <a:t>0.0138</a:t>
+                        <a:t>0.0104</a:t>
                       </a:r>
                     </a:p>
                   </a:txBody>
@@ -10428,7 +10428,7 @@
                           </a:solidFill>
                           <a:latin typeface="Arial"/>
                         </a:rPr>
-                        <a:t>1.0</a:t>
+                        <a:t>0.8</a:t>
                       </a:r>
                     </a:p>
                   </a:txBody>
@@ -10542,7 +10542,7 @@
                           </a:solidFill>
                           <a:latin typeface="Arial"/>
                         </a:rPr>
-                        <a:t>24,611</a:t>
+                        <a:t>24,967</a:t>
                       </a:r>
                     </a:p>
                   </a:txBody>
@@ -10570,7 +10570,7 @@
                           </a:solidFill>
                           <a:latin typeface="Arial"/>
                         </a:rPr>
-                        <a:t>1,322</a:t>
+                        <a:t>1,372</a:t>
                       </a:r>
                     </a:p>
                   </a:txBody>
@@ -10598,7 +10598,7 @@
                           </a:solidFill>
                           <a:latin typeface="Arial"/>
                         </a:rPr>
-                        <a:t>0.0706</a:t>
+                        <a:t>0.0722</a:t>
                       </a:r>
                     </a:p>
                   </a:txBody>
@@ -10654,7 +10654,7 @@
                           </a:solidFill>
                           <a:latin typeface="Arial"/>
                         </a:rPr>
-                        <a:t>0.0118</a:t>
+                        <a:t>0.0120</a:t>
                       </a:r>
                     </a:p>
                   </a:txBody>
@@ -10796,7 +10796,7 @@
                           </a:solidFill>
                           <a:latin typeface="Arial"/>
                         </a:rPr>
-                        <a:t>24,469</a:t>
+                        <a:t>24,396</a:t>
                       </a:r>
                     </a:p>
                   </a:txBody>
@@ -10824,7 +10824,7 @@
                           </a:solidFill>
                           <a:latin typeface="Arial"/>
                         </a:rPr>
-                        <a:t>242</a:t>
+                        <a:t>210</a:t>
                       </a:r>
                     </a:p>
                   </a:txBody>
@@ -10852,7 +10852,7 @@
                           </a:solidFill>
                           <a:latin typeface="Arial"/>
                         </a:rPr>
-                        <a:t>0.0514</a:t>
+                        <a:t>0.0509</a:t>
                       </a:r>
                     </a:p>
                   </a:txBody>
@@ -10908,7 +10908,7 @@
                           </a:solidFill>
                           <a:latin typeface="Arial"/>
                         </a:rPr>
-                        <a:t>0.0514</a:t>
+                        <a:t>0.0509</a:t>
                       </a:r>
                     </a:p>
                   </a:txBody>
@@ -11050,7 +11050,7 @@
                           </a:solidFill>
                           <a:latin typeface="Arial"/>
                         </a:rPr>
-                        <a:t>1,110</a:t>
+                        <a:t>1,108</a:t>
                       </a:r>
                     </a:p>
                   </a:txBody>
@@ -11078,7 +11078,7 @@
                           </a:solidFill>
                           <a:latin typeface="Arial"/>
                         </a:rPr>
-                        <a:t>71</a:t>
+                        <a:t>69</a:t>
                       </a:r>
                     </a:p>
                   </a:txBody>
@@ -11248,7 +11248,7 @@
                           </a:solidFill>
                           <a:latin typeface="Arial"/>
                         </a:rPr>
-                        <a:t>10</a:t>
+                        <a:t>9</a:t>
                       </a:r>
                     </a:p>
                   </a:txBody>
@@ -11276,7 +11276,7 @@
                           </a:solidFill>
                           <a:latin typeface="Arial"/>
                         </a:rPr>
-                        <a:t>60</a:t>
+                        <a:t>52</a:t>
                       </a:r>
                     </a:p>
                   </a:txBody>
@@ -11304,7 +11304,7 @@
                           </a:solidFill>
                           <a:latin typeface="Arial"/>
                         </a:rPr>
-                        <a:t>18,958</a:t>
+                        <a:t>18,466</a:t>
                       </a:r>
                     </a:p>
                   </a:txBody>
@@ -11332,7 +11332,7 @@
                           </a:solidFill>
                           <a:latin typeface="Arial"/>
                         </a:rPr>
-                        <a:t>3,495</a:t>
+                        <a:t>3,000</a:t>
                       </a:r>
                     </a:p>
                   </a:txBody>
@@ -11360,7 +11360,7 @@
                           </a:solidFill>
                           <a:latin typeface="Arial"/>
                         </a:rPr>
-                        <a:t>0.0729</a:t>
+                        <a:t>0.0669</a:t>
                       </a:r>
                     </a:p>
                   </a:txBody>
@@ -11444,7 +11444,7 @@
                           </a:solidFill>
                           <a:latin typeface="Arial"/>
                         </a:rPr>
-                        <a:t>1.8</a:t>
+                        <a:t>1.7</a:t>
                       </a:r>
                     </a:p>
                   </a:txBody>
@@ -11494,7 +11494,7 @@
                 </a:solidFill>
                 <a:latin typeface="Arial"/>
               </a:rPr>
-              <a:t>How to read it: one row per architecture, every model call it made, workers included. Compare USD per answer: flat at 0.0118 to 0.0148 except the handoff, whose two specialist calls each carried 7,017 inherited tokens. Recorded run on claude-opus-5 (lead) and claude-sonnet-5 (workers), 30 Sep 2026; live runs vary.</a:t>
+              <a:t>How to read it: one row per architecture, every model call it made, workers included. USD per answer: 0.0104 (orchestrator) to 0.0173 (lead); the handoff's specialist calls carried 6,965 inherited tokens each. Recorded run on opus-5 and sonnet-5, 2 Oct 2026; live runs vary.</a:t>
             </a:r>
           </a:p>
         </p:txBody>
@@ -18371,7 +18371,7 @@
                 </a:solidFill>
                 <a:latin typeface="Arial"/>
               </a:rPr>
-              <a:t>Notebook 04: 4 sub-questions, workers in parallel in 6.0 s, 0.0415 USD in all</a:t>
+              <a:t>Notebook 04: 3 sub-questions, workers in parallel in 4.2 s, 0.0311 USD in all</a:t>
             </a:r>
           </a:p>
         </p:txBody>
@@ -18598,7 +18598,7 @@
                 </a:solidFill>
                 <a:latin typeface="Arial"/>
               </a:rPr>
-              <a:t>Notebook 04: 3 sub-questions, delegations run one after another, 0.0444 USD in all</a:t>
+              <a:t>Notebook 04: 3 sub-questions, delegations run one after another, 0.0519 USD in all</a:t>
             </a:r>
           </a:p>
         </p:txBody>
@@ -19617,7 +19617,7 @@
                 </a:solidFill>
                 <a:latin typeface="Arial"/>
               </a:rPr>
-              <a:t>Handoffs and reviewer findings: Marmelab, The State of AI Harness Engineering 2026, Sep 2026. 15x tokens: Anthropic, Jun 2025. Delegation cap: notebook 04 exercise 1, recorded run: 2 workers started, 0 denied, 0.0424 USD.</a:t>
+              <a:t>Handoffs and reviewer findings: Marmelab, The State of AI Harness Engineering 2026, Sep 2026. 15x tokens: Anthropic, Jun 2025. Delegation cap: notebook 04 exercise 1, recorded run: 2 workers started, 0 denied, 0.0414 USD.</a:t>
             </a:r>
           </a:p>
         </p:txBody>

</xml_diff>